<commit_message>
docs: finalize course deliverables and team contributions
</commit_message>
<xml_diff>
--- a/deliverables/course/ChainGrade_课程答辩_重制版.pptx
+++ b/deliverables/course/ChainGrade_课程答辩_重制版.pptx
@@ -529,7 +529,7 @@
           <a:p>
             <a:r>
               <a:rPr lang="zh-CN" dirty="0"/>
-              <a:t>最后看工程指标。项目实现二十五个链码方法和二十五个 HTTP 路由，自动测试五十二项全部通过，其中 shared 六项、chaincode 二十项、API 二十六项。链码语句、分支、函数和行覆盖率分别为百分之八十五点九一、百分之七十五点三八、百分之九十五点五二和百分之八十五点九八。API 与 Web 从停止状态完成生产构建并进入健康状态耗时十二点五秒。我们也保留局限：分支覆盖仍低于其他指标，异常组合和完整 VC 互操作是下一阶段，而不是在本次答辩中夸大为已经完成。</a:t>
+              <a:t>最后看工程指标。项目实现二十五个链码方法和二十八个 HTTP 路由，一百二十项项目测试全部通过，另有七项基准工具测试通过。隔离性能矩阵包含七类负载、四档并发、每档三次，共八十四个正式单元，合法请求失败率为零；并发二十时公开验证吞吐中位数为每秒七百四十六点六一四次，P95 为三十八点二零二毫秒。单 orderer 稳定恢复需要二十二点四八二秒，因此这些数据证明可恢复性，但不证明写入高可用。</a:t>
             </a:r>
           </a:p>
         </p:txBody>
@@ -588,7 +588,7 @@
           <a:p>
             <a:r>
               <a:rPr lang="zh-CN" dirty="0"/>
-              <a:t>回到开头，ChainGrade 的价值不是把一个数字写进区块，而是把身份、复核、隐私、修订与申诉放进同一条可验证流程。我们已经完成真实 Fabric 双组织闭环、四角色产品，并用五十二项测试、双 Peer 一致性、真实交易和恢复彩排验证它。下一阶段的 VC 互操作和可靠性量化仍然服务同一个项目。谢谢各位老师，欢迎从为什么用链、如何保护隐私和证据是否真实三个角度提问。</a:t>
+              <a:t>回到开头，ChainGrade 的价值不是把一个数字写进区块，而是把身份、复核、隐私、修订与申诉放进同一条可验证流程。我们已经完成真实 Fabric 双组织闭环、四角色产品、标准 VC 文件互操作和可重复可靠性基准，并用一百二十项项目测试、双 Peer 一致性、真实交易、篡改失败和故障恢复时间验证它。下一步的 BBS+、三 orderer 和真实教务接入仍是明确边界。谢谢各位老师，欢迎从为什么用链、如何保护隐私和证据是否真实三个角度提问。</a:t>
             </a:r>
           </a:p>
         </p:txBody>
@@ -5586,9 +5586,9 @@
         <p:grpSpPr>
           <a:xfrm>
             <a:off x="667512" y="1695450"/>
-            <a:ext cx="2841127" cy="2175701"/>
+            <a:ext cx="4354601" cy="2175701"/>
             <a:chOff x="667512" y="1695450"/>
-            <a:chExt cx="2841127" cy="2175701"/>
+            <a:chExt cx="4354601" cy="2175701"/>
           </a:xfrm>
         </p:grpSpPr>
         <p:grpSp>
@@ -5830,7 +5830,7 @@
           <p:spPr>
             <a:xfrm>
               <a:off x="667512" y="2564130"/>
-              <a:ext cx="1741269" cy="704088"/>
+              <a:ext cx="2301019" cy="704088"/>
             </a:xfrm>
             <a:prstGeom prst="rect">
               <a:avLst/>
@@ -5856,7 +5856,7 @@
                   <a:ea typeface="+mn-ea"/>
                   <a:cs typeface="+mn-cs"/>
                 </a:rPr>
-                <a:t>52 / 52</a:t>
+                <a:t>120 / 120</a:t>
               </a:r>
             </a:p>
           </p:txBody>
@@ -5910,7 +5910,7 @@
           <p:spPr>
             <a:xfrm>
               <a:off x="678942" y="3607118"/>
-              <a:ext cx="2829697" cy="264033"/>
+              <a:ext cx="4343171" cy="264033"/>
             </a:xfrm>
             <a:prstGeom prst="rect">
               <a:avLst/>
@@ -5928,7 +5928,7 @@
             <a:p>
               <a:pPr algn="l"/>
               <a:r>
-                <a:rPr lang="en-US" sz="1350" dirty="0">
+                <a:rPr lang="zh-CN" sz="1350" dirty="0">
                   <a:solidFill>
                     <a:schemeClr val="accent5"/>
                   </a:solidFill>
@@ -5936,7 +5936,7 @@
                   <a:ea typeface="+mn-ea"/>
                   <a:cs typeface="+mn-cs"/>
                 </a:rPr>
-                <a:t>shared 6 · chaincode 20 · API 26</a:t>
+                <a:t>shared 33 · chaincode 20 · API 67 · 基准工具 7 / 7</a:t>
               </a:r>
             </a:p>
           </p:txBody>
@@ -6107,7 +6107,7 @@
                   <a:ea typeface="+mn-ea"/>
                   <a:cs typeface="+mn-cs"/>
                 </a:rPr>
-                <a:t>25</a:t>
+                <a:t>28</a:t>
               </a:r>
             </a:p>
           </p:txBody>
@@ -6776,7 +6776,7 @@
               </a:avLst>
             </a:prstGeom>
             <a:solidFill>
-              <a:srgbClr val="F9E8E8"/>
+              <a:srgbClr val="E7F1EC"/>
             </a:solidFill>
             <a:ln>
               <a:noFill/>
@@ -6792,7 +6792,7 @@
           <p:spPr>
             <a:xfrm>
               <a:off x="5955792" y="4769168"/>
-              <a:ext cx="4784312" cy="264033"/>
+              <a:ext cx="2952403" cy="264033"/>
             </a:xfrm>
             <a:prstGeom prst="rect">
               <a:avLst/>
@@ -6812,13 +6812,13 @@
               <a:r>
                 <a:rPr lang="zh-CN" sz="1350" b="1" dirty="0">
                   <a:solidFill>
-                    <a:srgbClr val="A13B3B"/>
-                  </a:solidFill>
-                  <a:latin typeface="+mn-lt"/>
-                  <a:ea typeface="+mn-ea"/>
-                  <a:cs typeface="+mn-cs"/>
-                </a:rPr>
-                <a:t>局限：分支覆盖低于其他指标，异常组合仍需继续补测。</a:t>
+                    <a:schemeClr val="accent6"/>
+                  </a:solidFill>
+                  <a:latin typeface="+mn-lt"/>
+                  <a:ea typeface="+mn-ea"/>
+                  <a:cs typeface="+mn-cs"/>
+                </a:rPr>
+                <a:t>84 个性能单元 · 合法请求失败率 0</a:t>
               </a:r>
             </a:p>
           </p:txBody>
@@ -7034,7 +7034,7 @@
           <p:spPr>
             <a:xfrm>
               <a:off x="1326642" y="5359718"/>
-              <a:ext cx="1277302" cy="264033"/>
+              <a:ext cx="4059679" cy="264033"/>
             </a:xfrm>
             <a:prstGeom prst="rect">
               <a:avLst/>
@@ -7060,7 +7060,7 @@
                   <a:ea typeface="+mn-ea"/>
                   <a:cs typeface="+mn-cs"/>
                 </a:rPr>
-                <a:t>API / Web 停止</a:t>
+                <a:t>公开验证 C20：746.614 次/秒 · P95 38.202 ms</a:t>
               </a:r>
             </a:p>
           </p:txBody>
@@ -7073,8 +7073,8 @@
           </p:nvSpPr>
           <p:spPr>
             <a:xfrm>
-              <a:off x="8417433" y="5359718"/>
-              <a:ext cx="1285875" cy="264033"/>
+              <a:off x="7972177" y="5359718"/>
+              <a:ext cx="1731131" cy="264033"/>
             </a:xfrm>
             <a:prstGeom prst="rect">
               <a:avLst/>
@@ -7100,7 +7100,7 @@
                   <a:ea typeface="+mn-ea"/>
                   <a:cs typeface="+mn-cs"/>
                 </a:rPr>
-                <a:t>生产构建后健康</a:t>
+                <a:t>单 orderer 稳定恢复</a:t>
               </a:r>
             </a:p>
           </p:txBody>
@@ -7113,8 +7113,8 @@
           </p:nvSpPr>
           <p:spPr>
             <a:xfrm>
-              <a:off x="9929576" y="5551170"/>
-              <a:ext cx="1398316" cy="469392"/>
+              <a:off x="9742993" y="5551170"/>
+              <a:ext cx="1584899" cy="469392"/>
             </a:xfrm>
             <a:prstGeom prst="rect">
               <a:avLst/>
@@ -7140,7 +7140,7 @@
                   <a:ea typeface="+mn-ea"/>
                   <a:cs typeface="+mn-cs"/>
                 </a:rPr>
-                <a:t>12.50 秒</a:t>
+                <a:t>22.482 秒</a:t>
               </a:r>
             </a:p>
           </p:txBody>
@@ -7169,7 +7169,7 @@
           <p:spPr>
             <a:xfrm>
               <a:off x="678942" y="6236018"/>
-              <a:ext cx="5147786" cy="264033"/>
+              <a:ext cx="5511260" cy="264033"/>
             </a:xfrm>
             <a:prstGeom prst="rect">
               <a:avLst/>
@@ -7195,7 +7195,7 @@
                   <a:ea typeface="+mn-ea"/>
                   <a:cs typeface="+mn-cs"/>
                 </a:rPr>
-                <a:t>数据来源：最终实验报告、coverage summary 与交付彩排记录</a:t>
+                <a:t>数据来源：最终实验报告、coverage summary 与隔离基准原始数据</a:t>
               </a:r>
             </a:p>
           </p:txBody>
@@ -7517,9 +7517,9 @@
         <p:grpSpPr>
           <a:xfrm>
             <a:off x="7194042" y="2377440"/>
-            <a:ext cx="3894264" cy="655511"/>
+            <a:ext cx="4119029" cy="655511"/>
             <a:chOff x="7194042" y="2377440"/>
-            <a:chExt cx="3894264" cy="655511"/>
+            <a:chExt cx="4119029" cy="655511"/>
           </a:xfrm>
         </p:grpSpPr>
         <p:sp>
@@ -7571,7 +7571,7 @@
           <p:spPr>
             <a:xfrm>
               <a:off x="8334756" y="2377440"/>
-              <a:ext cx="2753550" cy="352044"/>
+              <a:ext cx="2850462" cy="352044"/>
             </a:xfrm>
             <a:prstGeom prst="rect">
               <a:avLst/>
@@ -7597,7 +7597,7 @@
                   <a:ea typeface="+mn-ea"/>
                   <a:cs typeface="+mn-cs"/>
                 </a:rPr>
-                <a:t>真实 Fabric 双组织闭环</a:t>
+                <a:t>Fabric 双组织 · 标准 VC</a:t>
               </a:r>
             </a:p>
           </p:txBody>
@@ -7611,7 +7611,7 @@
           <p:spPr>
             <a:xfrm>
               <a:off x="8337042" y="2768918"/>
-              <a:ext cx="2376297" cy="264033"/>
+              <a:ext cx="2976029" cy="264033"/>
             </a:xfrm>
             <a:prstGeom prst="rect">
               <a:avLst/>
@@ -7637,7 +7637,7 @@
                   <a:ea typeface="+mn-ea"/>
                   <a:cs typeface="+mn-cs"/>
                 </a:rPr>
-                <a:t>四角色工作台与私有数据边界</a:t>
+                <a:t>四角色闭环与签名 / 状态 / 锚定验证</a:t>
               </a:r>
             </a:p>
           </p:txBody>
@@ -7652,9 +7652,9 @@
         <p:grpSpPr>
           <a:xfrm>
             <a:off x="7194042" y="3501390"/>
-            <a:ext cx="4165078" cy="655511"/>
+            <a:ext cx="4263070" cy="655511"/>
             <a:chOff x="7194042" y="3501390"/>
-            <a:chExt cx="4165078" cy="655511"/>
+            <a:chExt cx="4263070" cy="655511"/>
           </a:xfrm>
         </p:grpSpPr>
         <p:sp>
@@ -7706,7 +7706,7 @@
           <p:spPr>
             <a:xfrm>
               <a:off x="8334756" y="3501390"/>
-              <a:ext cx="3024364" cy="352044"/>
+              <a:ext cx="3122356" cy="352044"/>
             </a:xfrm>
             <a:prstGeom prst="rect">
               <a:avLst/>
@@ -7732,7 +7732,7 @@
                   <a:ea typeface="+mn-ea"/>
                   <a:cs typeface="+mn-cs"/>
                 </a:rPr>
-                <a:t>52 / 52 · 双 Peer 12 / 12</a:t>
+                <a:t>120 + 7 测试 · 84 性能单元</a:t>
               </a:r>
             </a:p>
           </p:txBody>
@@ -7746,7 +7746,7 @@
           <p:spPr>
             <a:xfrm>
               <a:off x="8337042" y="3892868"/>
-              <a:ext cx="2558034" cy="264033"/>
+              <a:ext cx="2921508" cy="264033"/>
             </a:xfrm>
             <a:prstGeom prst="rect">
               <a:avLst/>
@@ -7772,7 +7772,7 @@
                   <a:ea typeface="+mn-ea"/>
                   <a:cs typeface="+mn-cs"/>
                 </a:rPr>
-                <a:t>真实交易、原子失败与恢复彩排</a:t>
+                <a:t>真实交易、篡改失败与故障恢复时间</a:t>
               </a:r>
             </a:p>
           </p:txBody>
@@ -7787,9 +7787,9 @@
         <p:grpSpPr>
           <a:xfrm>
             <a:off x="7194042" y="4625340"/>
-            <a:ext cx="3995196" cy="655511"/>
+            <a:ext cx="4212280" cy="655511"/>
             <a:chOff x="7194042" y="4625340"/>
-            <a:chExt cx="3995196" cy="655511"/>
+            <a:chExt cx="4212280" cy="655511"/>
           </a:xfrm>
         </p:grpSpPr>
         <p:sp>
@@ -7841,7 +7841,7 @@
           <p:spPr>
             <a:xfrm>
               <a:off x="8334756" y="4625340"/>
-              <a:ext cx="2854482" cy="352044"/>
+              <a:ext cx="3071566" cy="352044"/>
             </a:xfrm>
             <a:prstGeom prst="rect">
               <a:avLst/>
@@ -7867,7 +7867,7 @@
                   <a:ea typeface="+mn-ea"/>
                   <a:cs typeface="+mn-cs"/>
                 </a:rPr>
-                <a:t>VC 互操作 · 可靠性量化</a:t>
+                <a:t>BBS+ · 三 orderer 高可用</a:t>
               </a:r>
             </a:p>
           </p:txBody>
@@ -7881,7 +7881,7 @@
           <p:spPr>
             <a:xfrm>
               <a:off x="8337042" y="5016818"/>
-              <a:ext cx="2558034" cy="264033"/>
+              <a:ext cx="2194560" cy="264033"/>
             </a:xfrm>
             <a:prstGeom prst="rect">
               <a:avLst/>
@@ -7907,7 +7907,7 @@
                   <a:ea typeface="+mn-ea"/>
                   <a:cs typeface="+mn-cs"/>
                 </a:rPr>
-                <a:t>两项工作包继续服务同一个项目</a:t>
+                <a:t>只把已有证据写成当前成果</a:t>
               </a:r>
             </a:p>
           </p:txBody>

</xml_diff>

<commit_message>
docs: finalize course submission materials
</commit_message>
<xml_diff>
--- a/deliverables/course/ChainGrade_课程答辩_重制版.pptx
+++ b/deliverables/course/ChainGrade_课程答辩_重制版.pptx
@@ -364,7 +364,7 @@
           <a:p>
             <a:r>
               <a:rPr lang="zh-CN" dirty="0"/>
-              <a:t>今天汇报的是 ChainGrade。我们没有把目标停在“把成绩写到链上”，而是希望一条成绩能够解释它从签发、复核到查询、纠错和验证的全过程。接下来会按问题、设计、证据和边界四部分展开。</a:t>
+              <a:t>今天汇报的是 ChainGrade。团队成员为组长魏子安，学号 3240101782；强璞，学号 3240102045；阳震，学号 3240105586。我们希望一条成绩能够解释它从签发、复核到查询、纠错和验证的全过程。接下来会按问题、设计、证据和边界四部分展开。</a:t>
             </a:r>
           </a:p>
         </p:txBody>
@@ -1249,7 +1249,7 @@
           <a:p>
             <a:r>
               <a:rPr lang="zh-CN" dirty="0"/>
-              <a:t>项目亮点可以概括为三点：完整的可信生命周期、适合低熵成绩数据的隐私承诺模型，以及链上状态和可携带 VC 的联合验证。团队贡献按组长四、两位组员各三分分配，总计十分。</a:t>
+              <a:t>项目亮点包括完整的可信生命周期、适合低熵成绩数据的隐私承诺模型，以及链上状态和可携带 VC 的联合验证。团队贡献按组长魏子安四分、强璞三分、阳震三分分配，总计十分；页面同步标明三人的学号。</a:t>
             </a:r>
           </a:p>
         </p:txBody>
@@ -2643,8 +2643,8 @@
         </p:nvSpPr>
         <p:spPr>
           <a:xfrm>
-            <a:off x="716661" y="5827871"/>
-            <a:ext cx="1792270" cy="278702"/>
+            <a:off x="717804" y="5833110"/>
+            <a:ext cx="2879598" cy="234696"/>
           </a:xfrm>
           <a:prstGeom prst="rect">
             <a:avLst/>
@@ -2662,7 +2662,7 @@
           <a:p>
             <a:pPr algn="l"/>
             <a:r>
-              <a:rPr lang="zh-CN" sz="1420" dirty="0">
+              <a:rPr lang="zh-CN" sz="1200" dirty="0">
                 <a:solidFill>
                   <a:schemeClr val="dk1"/>
                 </a:solidFill>
@@ -2670,7 +2670,47 @@
                 <a:ea typeface="+mn-ea"/>
                 <a:cs typeface="+mn-cs"/>
               </a:rPr>
-              <a:t>魏子安 · 强璞 · 阳震</a:t>
+              <a:t>魏子安 3240101782 · 强璞 3240102045</a:t>
+            </a:r>
+          </a:p>
+        </p:txBody>
+      </p:sp>
+      <p:sp>
+        <p:nvSpPr>
+          <p:cNvPr id="12" name="TextBox 12"/>
+          <p:cNvSpPr txBox="1"/>
+          <p:nvPr/>
+        </p:nvSpPr>
+        <p:spPr>
+          <a:xfrm>
+            <a:off x="717804" y="6090285"/>
+            <a:ext cx="1272235" cy="234696"/>
+          </a:xfrm>
+          <a:prstGeom prst="rect">
+            <a:avLst/>
+          </a:prstGeom>
+          <a:noFill/>
+          <a:ln>
+            <a:noFill/>
+          </a:ln>
+        </p:spPr>
+        <p:txBody>
+          <a:bodyPr wrap="none" lIns="0" tIns="0" rIns="0" bIns="0" anchor="t" anchorCtr="0">
+            <a:spAutoFit/>
+          </a:bodyPr>
+          <a:lstStyle/>
+          <a:p>
+            <a:pPr algn="l"/>
+            <a:r>
+              <a:rPr lang="zh-CN" sz="1200" dirty="0">
+                <a:solidFill>
+                  <a:schemeClr val="dk1"/>
+                </a:solidFill>
+                <a:latin typeface="+mn-lt"/>
+                <a:ea typeface="+mn-ea"/>
+                <a:cs typeface="+mn-cs"/>
+              </a:rPr>
+              <a:t>阳震 3240105586</a:t>
             </a:r>
           </a:p>
         </p:txBody>
@@ -18831,16 +18871,16 @@
       </p:grpSp>
       <p:grpSp>
         <p:nvGrpSpPr>
-          <p:cNvPr id="40" name="Group 40"/>
+          <p:cNvPr id="43" name="Group 43"/>
           <p:cNvGrpSpPr/>
           <p:nvPr/>
         </p:nvGrpSpPr>
         <p:grpSpPr>
           <a:xfrm>
             <a:off x="685800" y="4895850"/>
-            <a:ext cx="10820400" cy="990600"/>
+            <a:ext cx="10820400" cy="1009364"/>
             <a:chOff x="685800" y="4895850"/>
-            <a:chExt cx="10820400" cy="990600"/>
+            <a:chExt cx="10820400" cy="1009364"/>
           </a:xfrm>
         </p:grpSpPr>
         <p:sp>
@@ -18951,7 +18991,47 @@
         </p:sp>
         <p:sp>
           <p:nvSpPr>
-            <p:cNvPr id="32" name="Rectangle 32"/>
+            <p:cNvPr id="32" name="TextBox 32"/>
+            <p:cNvSpPr txBox="1"/>
+            <p:nvPr/>
+          </p:nvSpPr>
+          <p:spPr>
+            <a:xfrm>
+              <a:off x="2719197" y="5304949"/>
+              <a:ext cx="735508" cy="190690"/>
+            </a:xfrm>
+            <a:prstGeom prst="rect">
+              <a:avLst/>
+            </a:prstGeom>
+            <a:noFill/>
+            <a:ln>
+              <a:noFill/>
+            </a:ln>
+          </p:spPr>
+          <p:txBody>
+            <a:bodyPr wrap="none" lIns="0" tIns="0" rIns="0" bIns="0" anchor="t" anchorCtr="0">
+              <a:spAutoFit/>
+            </a:bodyPr>
+            <a:lstStyle/>
+            <a:p>
+              <a:pPr algn="l"/>
+              <a:r>
+                <a:rPr lang="en-US" sz="980" dirty="0">
+                  <a:solidFill>
+                    <a:schemeClr val="accent5"/>
+                  </a:solidFill>
+                  <a:latin typeface="+mn-lt"/>
+                  <a:ea typeface="+mn-ea"/>
+                  <a:cs typeface="+mn-cs"/>
+                </a:rPr>
+                <a:t>3240101782</a:t>
+              </a:r>
+            </a:p>
+          </p:txBody>
+        </p:sp>
+        <p:sp>
+          <p:nvSpPr>
+            <p:cNvPr id="33" name="Rectangle 33"/>
             <p:cNvSpPr/>
             <p:nvPr/>
           </p:nvSpPr>
@@ -18973,7 +19053,7 @@
         </p:sp>
         <p:sp>
           <p:nvSpPr>
-            <p:cNvPr id="33" name="TextBox 33"/>
+            <p:cNvPr id="34" name="TextBox 34"/>
             <p:cNvSpPr txBox="1"/>
             <p:nvPr/>
           </p:nvSpPr>
@@ -19013,7 +19093,7 @@
         </p:sp>
         <p:sp>
           <p:nvSpPr>
-            <p:cNvPr id="34" name="TextBox 34"/>
+            <p:cNvPr id="35" name="TextBox 35"/>
             <p:cNvSpPr txBox="1"/>
             <p:nvPr/>
           </p:nvSpPr>
@@ -19053,7 +19133,47 @@
         </p:sp>
         <p:sp>
           <p:nvSpPr>
-            <p:cNvPr id="35" name="Rectangle 35"/>
+            <p:cNvPr id="36" name="TextBox 36"/>
+            <p:cNvSpPr txBox="1"/>
+            <p:nvPr/>
+          </p:nvSpPr>
+          <p:spPr>
+            <a:xfrm>
+              <a:off x="7234047" y="5304949"/>
+              <a:ext cx="735508" cy="190690"/>
+            </a:xfrm>
+            <a:prstGeom prst="rect">
+              <a:avLst/>
+            </a:prstGeom>
+            <a:noFill/>
+            <a:ln>
+              <a:noFill/>
+            </a:ln>
+          </p:spPr>
+          <p:txBody>
+            <a:bodyPr wrap="none" lIns="0" tIns="0" rIns="0" bIns="0" anchor="t" anchorCtr="0">
+              <a:spAutoFit/>
+            </a:bodyPr>
+            <a:lstStyle/>
+            <a:p>
+              <a:pPr algn="l"/>
+              <a:r>
+                <a:rPr lang="en-US" sz="980" dirty="0">
+                  <a:solidFill>
+                    <a:schemeClr val="accent5"/>
+                  </a:solidFill>
+                  <a:latin typeface="+mn-lt"/>
+                  <a:ea typeface="+mn-ea"/>
+                  <a:cs typeface="+mn-cs"/>
+                </a:rPr>
+                <a:t>3240102045</a:t>
+              </a:r>
+            </a:p>
+          </p:txBody>
+        </p:sp>
+        <p:sp>
+          <p:nvSpPr>
+            <p:cNvPr id="37" name="Rectangle 37"/>
             <p:cNvSpPr/>
             <p:nvPr/>
           </p:nvSpPr>
@@ -19075,7 +19195,7 @@
         </p:sp>
         <p:sp>
           <p:nvSpPr>
-            <p:cNvPr id="36" name="TextBox 36"/>
+            <p:cNvPr id="38" name="TextBox 38"/>
             <p:cNvSpPr txBox="1"/>
             <p:nvPr/>
           </p:nvSpPr>
@@ -19115,7 +19235,7 @@
         </p:sp>
         <p:sp>
           <p:nvSpPr>
-            <p:cNvPr id="37" name="TextBox 37"/>
+            <p:cNvPr id="39" name="TextBox 39"/>
             <p:cNvSpPr txBox="1"/>
             <p:nvPr/>
           </p:nvSpPr>
@@ -19155,7 +19275,47 @@
         </p:sp>
         <p:sp>
           <p:nvSpPr>
-            <p:cNvPr id="38" name="Rectangle 38"/>
+            <p:cNvPr id="40" name="TextBox 40"/>
+            <p:cNvSpPr txBox="1"/>
+            <p:nvPr/>
+          </p:nvSpPr>
+          <p:spPr>
+            <a:xfrm>
+              <a:off x="2719197" y="5714524"/>
+              <a:ext cx="735508" cy="190690"/>
+            </a:xfrm>
+            <a:prstGeom prst="rect">
+              <a:avLst/>
+            </a:prstGeom>
+            <a:noFill/>
+            <a:ln>
+              <a:noFill/>
+            </a:ln>
+          </p:spPr>
+          <p:txBody>
+            <a:bodyPr wrap="none" lIns="0" tIns="0" rIns="0" bIns="0" anchor="t" anchorCtr="0">
+              <a:spAutoFit/>
+            </a:bodyPr>
+            <a:lstStyle/>
+            <a:p>
+              <a:pPr algn="l"/>
+              <a:r>
+                <a:rPr lang="en-US" sz="980" dirty="0">
+                  <a:solidFill>
+                    <a:schemeClr val="accent5"/>
+                  </a:solidFill>
+                  <a:latin typeface="+mn-lt"/>
+                  <a:ea typeface="+mn-ea"/>
+                  <a:cs typeface="+mn-cs"/>
+                </a:rPr>
+                <a:t>3240105586</a:t>
+              </a:r>
+            </a:p>
+          </p:txBody>
+        </p:sp>
+        <p:sp>
+          <p:nvSpPr>
+            <p:cNvPr id="41" name="Rectangle 41"/>
             <p:cNvSpPr/>
             <p:nvPr/>
           </p:nvSpPr>
@@ -19177,7 +19337,7 @@
         </p:sp>
         <p:sp>
           <p:nvSpPr>
-            <p:cNvPr id="39" name="TextBox 39"/>
+            <p:cNvPr id="42" name="TextBox 42"/>
             <p:cNvSpPr txBox="1"/>
             <p:nvPr/>
           </p:nvSpPr>
@@ -19218,7 +19378,7 @@
       </p:grpSp>
       <p:grpSp>
         <p:nvGrpSpPr>
-          <p:cNvPr id="43" name="Group 43"/>
+          <p:cNvPr id="46" name="Group 46"/>
           <p:cNvGrpSpPr/>
           <p:nvPr/>
         </p:nvGrpSpPr>
@@ -19232,7 +19392,7 @@
         </p:grpSpPr>
         <p:sp>
           <p:nvSpPr>
-            <p:cNvPr id="41" name="TextBox 41"/>
+            <p:cNvPr id="44" name="TextBox 44"/>
             <p:cNvSpPr txBox="1"/>
             <p:nvPr/>
           </p:nvSpPr>
@@ -19272,7 +19432,7 @@
         </p:sp>
         <p:sp>
           <p:nvSpPr>
-            <p:cNvPr id="42" name="TextBox 42"/>
+            <p:cNvPr id="45" name="TextBox 45"/>
             <p:cNvSpPr txBox="1"/>
             <p:nvPr/>
           </p:nvSpPr>

</xml_diff>